<commit_message>
fix(fenrix-submission): demo-evidence uses confirmed_count + current SHA; ruff format
- build_demo_evidence.py: use confirmed_count/mechanisms_evaluated (new keys);
  UI 'failure_count' now maps to CONFIRMED (repeated-seed) failures, not raw candidates
- demo evidence bundle + recording regenerated at current HEAD (85abadc);
  page shows current git SHA + strategy hash c9d19b2e
- ruff format across repo (23 files, mostly subagent audit tests)
</commit_message>
<xml_diff>
--- a/app/static/pitch-deck/fenrix_deck.pptx
+++ b/app/static/pitch-deck/fenrix_deck.pptx
@@ -3206,7 +3206,7 @@
               </a:defRPr>
             </a:pPr>
             <a:r>
-              <a:t>• git SHA: dadce86e53c42573 · data mode of record: yfinance · universe: 30 assets</a:t>
+              <a:t>• git SHA: 85abadc8786e71c7 · data mode of record: yfinance · universe: 30 assets</a:t>
             </a:r>
           </a:p>
         </p:txBody>
@@ -4147,7 +4147,7 @@
               </a:defRPr>
             </a:pPr>
             <a:r>
-              <a:t>TIER 2 · yfinance historical (actual run) · git dadce86e53c42573 · evidence-generated · not investment advice</a:t>
+              <a:t>TIER 2 · yfinance historical (actual run) · git 85abadc8786e71c7 · evidence-generated · not investment advice</a:t>
             </a:r>
           </a:p>
         </p:txBody>
@@ -4314,7 +4314,7 @@
               </a:defRPr>
             </a:pPr>
             <a:r>
-              <a:t>TIER 2 · yfinance historical (actual run) · git dadce86e53c42573 · evidence-generated · not investment advice</a:t>
+              <a:t>TIER 2 · yfinance historical (actual run) · git 85abadc8786e71c7 · evidence-generated · not investment advice</a:t>
             </a:r>
           </a:p>
         </p:txBody>
@@ -4493,7 +4493,7 @@
               </a:defRPr>
             </a:pPr>
             <a:r>
-              <a:t>TIER 2 · yfinance historical (actual run) · git dadce86e53c42573 · evidence-generated · not investment advice</a:t>
+              <a:t>TIER 2 · yfinance historical (actual run) · git 85abadc8786e71c7 · evidence-generated · not investment advice</a:t>
             </a:r>
           </a:p>
         </p:txBody>

</xml_diff>

<commit_message>
fix(fenrix-submission): wire SPY benchmark into yfinance panel; honest active return
- acquire_panel now fetches SPY alongside the 30-name universe; yfinance adapter
  extracts SPY as benchmark_close and REMOVES it from the tradable universe
  (both fresh-fetch _normalize_yf and _load_cache paths)
- engine benchmark metrics now robust to NaN-leading/partial series (first&last
  finite,>0 indices; correct geometric span)
- RESULT: benchmark_cagr=12.49% (SPY) vs strategy cagr=1.26%, information_ratio
  =-0.468 — deck now honestly shows strategy UNDERPERFORMS SPY (spec 4/honesty)
- deck + demo-evidence + browser recording regenerated at HEAD; SPY line renders
- tests updated: run-of-record (SPY=benchmark not tradable), benchmark_cagr span
</commit_message>
<xml_diff>
--- a/app/static/pitch-deck/fenrix_deck.pptx
+++ b/app/static/pitch-deck/fenrix_deck.pptx
@@ -3206,7 +3206,7 @@
               </a:defRPr>
             </a:pPr>
             <a:r>
-              <a:t>• git SHA: 85abadc8786e71c7 · data mode of record: yfinance · universe: 30 assets</a:t>
+              <a:t>• git SHA: 822ef51ebd0601f2 · data mode of record: yfinance · universe: 30 assets</a:t>
             </a:r>
           </a:p>
         </p:txBody>
@@ -4064,7 +4064,7 @@
               </a:defRPr>
             </a:pPr>
             <a:r>
-              <a:t>• Benchmark CAGR n/a · information ratio n/a</a:t>
+              <a:t>• Benchmark CAGR 12.49% · information ratio -0.47</a:t>
             </a:r>
           </a:p>
           <a:p>
@@ -4147,7 +4147,7 @@
               </a:defRPr>
             </a:pPr>
             <a:r>
-              <a:t>TIER 2 · yfinance historical (actual run) · git 85abadc8786e71c7 · evidence-generated · not investment advice</a:t>
+              <a:t>TIER 2 · yfinance historical (actual run) · git 822ef51ebd0601f2 · evidence-generated · not investment advice</a:t>
             </a:r>
           </a:p>
         </p:txBody>
@@ -4314,7 +4314,7 @@
               </a:defRPr>
             </a:pPr>
             <a:r>
-              <a:t>TIER 2 · yfinance historical (actual run) · git 85abadc8786e71c7 · evidence-generated · not investment advice</a:t>
+              <a:t>TIER 2 · yfinance historical (actual run) · git 822ef51ebd0601f2 · evidence-generated · not investment advice</a:t>
             </a:r>
           </a:p>
         </p:txBody>
@@ -4493,7 +4493,7 @@
               </a:defRPr>
             </a:pPr>
             <a:r>
-              <a:t>TIER 2 · yfinance historical (actual run) · git 85abadc8786e71c7 · evidence-generated · not investment advice</a:t>
+              <a:t>TIER 2 · yfinance historical (actual run) · git 822ef51ebd0601f2 · evidence-generated · not investment advice</a:t>
             </a:r>
           </a:p>
         </p:txBody>

</xml_diff>

<commit_message>
chore(fenrix-submission): regenerate deck + demo evidence at HEAD (honest SPY benchmark)
- fenrix_deck.pptx/pdf, pitch-deck/index.html, submission_demo_evidence.json
  regenerated from d012a6c yfinance run: cagr 1.26% vs SPY 12.49%, IR -0.468
</commit_message>
<xml_diff>
--- a/app/static/pitch-deck/fenrix_deck.pptx
+++ b/app/static/pitch-deck/fenrix_deck.pptx
@@ -3206,7 +3206,7 @@
               </a:defRPr>
             </a:pPr>
             <a:r>
-              <a:t>• git SHA: 822ef51ebd0601f2 · data mode of record: yfinance · universe: 30 assets</a:t>
+              <a:t>• git SHA: d012a6c1ee8f2ead · data mode of record: yfinance · universe: 30 assets</a:t>
             </a:r>
           </a:p>
         </p:txBody>
@@ -4147,7 +4147,7 @@
               </a:defRPr>
             </a:pPr>
             <a:r>
-              <a:t>TIER 2 · yfinance historical (actual run) · git 822ef51ebd0601f2 · evidence-generated · not investment advice</a:t>
+              <a:t>TIER 2 · yfinance historical (actual run) · git d012a6c1ee8f2ead · evidence-generated · not investment advice</a:t>
             </a:r>
           </a:p>
         </p:txBody>
@@ -4314,7 +4314,7 @@
               </a:defRPr>
             </a:pPr>
             <a:r>
-              <a:t>TIER 2 · yfinance historical (actual run) · git 822ef51ebd0601f2 · evidence-generated · not investment advice</a:t>
+              <a:t>TIER 2 · yfinance historical (actual run) · git d012a6c1ee8f2ead · evidence-generated · not investment advice</a:t>
             </a:r>
           </a:p>
         </p:txBody>
@@ -4493,7 +4493,7 @@
               </a:defRPr>
             </a:pPr>
             <a:r>
-              <a:t>TIER 2 · yfinance historical (actual run) · git 822ef51ebd0601f2 · evidence-generated · not investment advice</a:t>
+              <a:t>TIER 2 · yfinance historical (actual run) · git d012a6c1ee8f2ead · evidence-generated · not investment advice</a:t>
             </a:r>
           </a:p>
         </p:txBody>

</xml_diff>

<commit_message>
fix(fenrix-submission): deck equity chart overlays REAL SPY benchmark line
- BacktestResult now carries benchmark_close; orchestrator threads it into payload
- evidence.py writes benchmark_curve.csv as SPY rebased to initial capital
  (was a constant flat line = benchmark_cagr scalar bug)
- deck._render_equity_chart overlays orange dashed 'SPY (rebased)' with legend
- chart now honestly shows strategy ($1.10M) UNDERPERFORMING SPY ($2.56M)
- deck + demo-evidence + recording regenerated at HEAD
</commit_message>
<xml_diff>
--- a/app/static/pitch-deck/fenrix_deck.pptx
+++ b/app/static/pitch-deck/fenrix_deck.pptx
@@ -3206,7 +3206,7 @@
               </a:defRPr>
             </a:pPr>
             <a:r>
-              <a:t>• git SHA: d012a6c1ee8f2ead · data mode of record: yfinance · universe: 30 assets</a:t>
+              <a:t>• git SHA: 504c6cffde1de3ab · data mode of record: yfinance · universe: 30 assets</a:t>
             </a:r>
           </a:p>
         </p:txBody>
@@ -4147,7 +4147,7 @@
               </a:defRPr>
             </a:pPr>
             <a:r>
-              <a:t>TIER 2 · yfinance historical (actual run) · git d012a6c1ee8f2ead · evidence-generated · not investment advice</a:t>
+              <a:t>TIER 2 · yfinance historical (actual run) · git 504c6cffde1de3ab · evidence-generated · not investment advice</a:t>
             </a:r>
           </a:p>
         </p:txBody>
@@ -4314,7 +4314,7 @@
               </a:defRPr>
             </a:pPr>
             <a:r>
-              <a:t>TIER 2 · yfinance historical (actual run) · git d012a6c1ee8f2ead · evidence-generated · not investment advice</a:t>
+              <a:t>TIER 2 · yfinance historical (actual run) · git 504c6cffde1de3ab · evidence-generated · not investment advice</a:t>
             </a:r>
           </a:p>
         </p:txBody>
@@ -4493,7 +4493,7 @@
               </a:defRPr>
             </a:pPr>
             <a:r>
-              <a:t>TIER 2 · yfinance historical (actual run) · git d012a6c1ee8f2ead · evidence-generated · not investment advice</a:t>
+              <a:t>TIER 2 · yfinance historical (actual run) · git 504c6cffde1de3ab · evidence-generated · not investment advice</a:t>
             </a:r>
           </a:p>
         </p:txBody>

</xml_diff>

<commit_message>
chore(fenrix-submission): regenerate committed deck + demo evidence at final HEAD
- fenrix_deck.pptx/pdf, pitch-deck/index.html, submission_demo_evidence.json
  rebuilt at c2f0918 so committed evidence git_sha matches branch HEAD
</commit_message>
<xml_diff>
--- a/app/static/pitch-deck/fenrix_deck.pptx
+++ b/app/static/pitch-deck/fenrix_deck.pptx
@@ -3206,7 +3206,7 @@
               </a:defRPr>
             </a:pPr>
             <a:r>
-              <a:t>• git SHA: 504c6cffde1de3ab · data mode of record: yfinance · universe: 30 assets</a:t>
+              <a:t>• git SHA: c2f09189e8c4ca7d · data mode of record: yfinance · universe: 30 assets</a:t>
             </a:r>
           </a:p>
         </p:txBody>
@@ -4147,7 +4147,7 @@
               </a:defRPr>
             </a:pPr>
             <a:r>
-              <a:t>TIER 2 · yfinance historical (actual run) · git 504c6cffde1de3ab · evidence-generated · not investment advice</a:t>
+              <a:t>TIER 2 · yfinance historical (actual run) · git c2f09189e8c4ca7d · evidence-generated · not investment advice</a:t>
             </a:r>
           </a:p>
         </p:txBody>
@@ -4314,7 +4314,7 @@
               </a:defRPr>
             </a:pPr>
             <a:r>
-              <a:t>TIER 2 · yfinance historical (actual run) · git 504c6cffde1de3ab · evidence-generated · not investment advice</a:t>
+              <a:t>TIER 2 · yfinance historical (actual run) · git c2f09189e8c4ca7d · evidence-generated · not investment advice</a:t>
             </a:r>
           </a:p>
         </p:txBody>
@@ -4493,7 +4493,7 @@
               </a:defRPr>
             </a:pPr>
             <a:r>
-              <a:t>TIER 2 · yfinance historical (actual run) · git 504c6cffde1de3ab · evidence-generated · not investment advice</a:t>
+              <a:t>TIER 2 · yfinance historical (actual run) · git c2f09189e8c4ca7d · evidence-generated · not investment advice</a:t>
             </a:r>
           </a:p>
         </p:txBody>

</xml_diff>

<commit_message>
chore(fenrix-submission): regenerate deck + evidence stamped at HEAD 0327c8b (full git sha)
</commit_message>
<xml_diff>
--- a/app/static/pitch-deck/fenrix_deck.pptx
+++ b/app/static/pitch-deck/fenrix_deck.pptx
@@ -3206,7 +3206,7 @@
               </a:defRPr>
             </a:pPr>
             <a:r>
-              <a:t>• git SHA: 8e659ca5e4c5839225b43f8815d557272ebb602e · data mode of record: yfinance · universe: 30 assets</a:t>
+              <a:t>• git SHA: 0327c8b7c6ebf0bd599d15aef6c69b1bf15f5090 · data mode of record: yfinance · universe: 30 assets</a:t>
             </a:r>
           </a:p>
         </p:txBody>
@@ -4147,7 +4147,7 @@
               </a:defRPr>
             </a:pPr>
             <a:r>
-              <a:t>TIER 2 · yfinance historical (actual run) · git 8e659ca5e4c5839225b43f8815d557272ebb602e · evidence-generated · not investment advice</a:t>
+              <a:t>TIER 2 · yfinance historical (actual run) · git 0327c8b7c6ebf0bd599d15aef6c69b1bf15f5090 · evidence-generated · not investment advice</a:t>
             </a:r>
           </a:p>
         </p:txBody>
@@ -4314,7 +4314,7 @@
               </a:defRPr>
             </a:pPr>
             <a:r>
-              <a:t>TIER 2 · yfinance historical (actual run) · git 8e659ca5e4c5839225b43f8815d557272ebb602e · evidence-generated · not investment advice</a:t>
+              <a:t>TIER 2 · yfinance historical (actual run) · git 0327c8b7c6ebf0bd599d15aef6c69b1bf15f5090 · evidence-generated · not investment advice</a:t>
             </a:r>
           </a:p>
         </p:txBody>
@@ -4493,7 +4493,7 @@
               </a:defRPr>
             </a:pPr>
             <a:r>
-              <a:t>TIER 2 · yfinance historical (actual run) · git 8e659ca5e4c5839225b43f8815d557272ebb602e · evidence-generated · not investment advice</a:t>
+              <a:t>TIER 2 · yfinance historical (actual run) · git 0327c8b7c6ebf0bd599d15aef6c69b1bf15f5090 · evidence-generated · not investment advice</a:t>
             </a:r>
           </a:p>
         </p:txBody>

</xml_diff>

<commit_message>
chore(fenrix-submission): regenerate deck from yfinance evidence dir at HEAD 0170603 (data_mode=yfinance)
</commit_message>
<xml_diff>
--- a/app/static/pitch-deck/fenrix_deck.pptx
+++ b/app/static/pitch-deck/fenrix_deck.pptx
@@ -3206,7 +3206,7 @@
               </a:defRPr>
             </a:pPr>
             <a:r>
-              <a:t>• git SHA: 0327c8b7c6ebf0bd599d15aef6c69b1bf15f5090 · data mode of record: yfinance · universe: 30 assets</a:t>
+              <a:t>• git SHA: 0170603adfc3dfc19fce4bc8440a32423e9ea557 · data mode of record: yfinance · universe: 30 assets</a:t>
             </a:r>
           </a:p>
         </p:txBody>
@@ -4147,7 +4147,7 @@
               </a:defRPr>
             </a:pPr>
             <a:r>
-              <a:t>TIER 2 · yfinance historical (actual run) · git 0327c8b7c6ebf0bd599d15aef6c69b1bf15f5090 · evidence-generated · not investment advice</a:t>
+              <a:t>TIER 2 · yfinance historical (actual run) · git 0170603adfc3dfc19fce4bc8440a32423e9ea557 · evidence-generated · not investment advice</a:t>
             </a:r>
           </a:p>
         </p:txBody>
@@ -4314,7 +4314,7 @@
               </a:defRPr>
             </a:pPr>
             <a:r>
-              <a:t>TIER 2 · yfinance historical (actual run) · git 0327c8b7c6ebf0bd599d15aef6c69b1bf15f5090 · evidence-generated · not investment advice</a:t>
+              <a:t>TIER 2 · yfinance historical (actual run) · git 0170603adfc3dfc19fce4bc8440a32423e9ea557 · evidence-generated · not investment advice</a:t>
             </a:r>
           </a:p>
         </p:txBody>
@@ -4493,7 +4493,7 @@
               </a:defRPr>
             </a:pPr>
             <a:r>
-              <a:t>TIER 2 · yfinance historical (actual run) · git 0327c8b7c6ebf0bd599d15aef6c69b1bf15f5090 · evidence-generated · not investment advice</a:t>
+              <a:t>TIER 2 · yfinance historical (actual run) · git 0170603adfc3dfc19fce4bc8440a32423e9ea557 · evidence-generated · not investment advice</a:t>
             </a:r>
           </a:p>
         </p:txBody>

</xml_diff>

<commit_message>
test(fenrix-submission): _latest_package prefers HEAD-matched evidence dir (deterministic audit, no synthetic shadowing)
</commit_message>
<xml_diff>
--- a/app/static/pitch-deck/fenrix_deck.pptx
+++ b/app/static/pitch-deck/fenrix_deck.pptx
@@ -3206,7 +3206,7 @@
               </a:defRPr>
             </a:pPr>
             <a:r>
-              <a:t>• git SHA: 0170603adfc3dfc19fce4bc8440a32423e9ea557 · data mode of record: yfinance · universe: 30 assets</a:t>
+              <a:t>• git SHA: 49e98cdff0cf647c0dbe98687352d016aed10c38 · data mode of record: yfinance · universe: 30 assets</a:t>
             </a:r>
           </a:p>
         </p:txBody>
@@ -4147,7 +4147,7 @@
               </a:defRPr>
             </a:pPr>
             <a:r>
-              <a:t>TIER 2 · yfinance historical (actual run) · git 0170603adfc3dfc19fce4bc8440a32423e9ea557 · evidence-generated · not investment advice</a:t>
+              <a:t>TIER 2 · yfinance historical (actual run) · git 49e98cdff0cf647c0dbe98687352d016aed10c38 · evidence-generated · not investment advice</a:t>
             </a:r>
           </a:p>
         </p:txBody>
@@ -4314,7 +4314,7 @@
               </a:defRPr>
             </a:pPr>
             <a:r>
-              <a:t>TIER 2 · yfinance historical (actual run) · git 0170603adfc3dfc19fce4bc8440a32423e9ea557 · evidence-generated · not investment advice</a:t>
+              <a:t>TIER 2 · yfinance historical (actual run) · git 49e98cdff0cf647c0dbe98687352d016aed10c38 · evidence-generated · not investment advice</a:t>
             </a:r>
           </a:p>
         </p:txBody>
@@ -4493,7 +4493,7 @@
               </a:defRPr>
             </a:pPr>
             <a:r>
-              <a:t>TIER 2 · yfinance historical (actual run) · git 0170603adfc3dfc19fce4bc8440a32423e9ea557 · evidence-generated · not investment advice</a:t>
+              <a:t>TIER 2 · yfinance historical (actual run) · git 49e98cdff0cf647c0dbe98687352d016aed10c38 · evidence-generated · not investment advice</a:t>
             </a:r>
           </a:p>
         </p:txBody>

</xml_diff>

<commit_message>
chore(fenrix-submission): regenerate deck stamped at HEAD 4047c24 (evidence dir matches full sha)
</commit_message>
<xml_diff>
--- a/app/static/pitch-deck/fenrix_deck.pptx
+++ b/app/static/pitch-deck/fenrix_deck.pptx
@@ -3206,7 +3206,7 @@
               </a:defRPr>
             </a:pPr>
             <a:r>
-              <a:t>• git SHA: 49e98cdff0cf647c0dbe98687352d016aed10c38 · data mode of record: yfinance · universe: 30 assets</a:t>
+              <a:t>• git SHA: 4047c245bd417aaa6c31e083d57747197f22e9cc · data mode of record: yfinance · universe: 30 assets</a:t>
             </a:r>
           </a:p>
         </p:txBody>
@@ -4147,7 +4147,7 @@
               </a:defRPr>
             </a:pPr>
             <a:r>
-              <a:t>TIER 2 · yfinance historical (actual run) · git 49e98cdff0cf647c0dbe98687352d016aed10c38 · evidence-generated · not investment advice</a:t>
+              <a:t>TIER 2 · yfinance historical (actual run) · git 4047c245bd417aaa6c31e083d57747197f22e9cc · evidence-generated · not investment advice</a:t>
             </a:r>
           </a:p>
         </p:txBody>
@@ -4314,7 +4314,7 @@
               </a:defRPr>
             </a:pPr>
             <a:r>
-              <a:t>TIER 2 · yfinance historical (actual run) · git 49e98cdff0cf647c0dbe98687352d016aed10c38 · evidence-generated · not investment advice</a:t>
+              <a:t>TIER 2 · yfinance historical (actual run) · git 4047c245bd417aaa6c31e083d57747197f22e9cc · evidence-generated · not investment advice</a:t>
             </a:r>
           </a:p>
         </p:txBody>
@@ -4493,7 +4493,7 @@
               </a:defRPr>
             </a:pPr>
             <a:r>
-              <a:t>TIER 2 · yfinance historical (actual run) · git 49e98cdff0cf647c0dbe98687352d016aed10c38 · evidence-generated · not investment advice</a:t>
+              <a:t>TIER 2 · yfinance historical (actual run) · git 4047c245bd417aaa6c31e083d57747197f22e9cc · evidence-generated · not investment advice</a:t>
             </a:r>
           </a:p>
         </p:txBody>

</xml_diff>

<commit_message>
fix(fenrix-submission): verify-submission writes to <sha>-verify dir, never clobbers yfinance run-of-record
</commit_message>
<xml_diff>
--- a/app/static/pitch-deck/fenrix_deck.pptx
+++ b/app/static/pitch-deck/fenrix_deck.pptx
@@ -3206,7 +3206,7 @@
               </a:defRPr>
             </a:pPr>
             <a:r>
-              <a:t>• git SHA: 4047c245bd417aaa6c31e083d57747197f22e9cc · data mode of record: yfinance · universe: 30 assets</a:t>
+              <a:t>• git SHA: 07bbbcfa9242ec07a19bb30fb54e4880de94ae56 · data mode of record: yfinance · universe: 30 assets</a:t>
             </a:r>
           </a:p>
         </p:txBody>
@@ -4147,7 +4147,7 @@
               </a:defRPr>
             </a:pPr>
             <a:r>
-              <a:t>TIER 2 · yfinance historical (actual run) · git 4047c245bd417aaa6c31e083d57747197f22e9cc · evidence-generated · not investment advice</a:t>
+              <a:t>TIER 2 · yfinance historical (actual run) · git 07bbbcfa9242ec07a19bb30fb54e4880de94ae56 · evidence-generated · not investment advice</a:t>
             </a:r>
           </a:p>
         </p:txBody>
@@ -4314,7 +4314,7 @@
               </a:defRPr>
             </a:pPr>
             <a:r>
-              <a:t>TIER 2 · yfinance historical (actual run) · git 4047c245bd417aaa6c31e083d57747197f22e9cc · evidence-generated · not investment advice</a:t>
+              <a:t>TIER 2 · yfinance historical (actual run) · git 07bbbcfa9242ec07a19bb30fb54e4880de94ae56 · evidence-generated · not investment advice</a:t>
             </a:r>
           </a:p>
         </p:txBody>
@@ -4493,7 +4493,7 @@
               </a:defRPr>
             </a:pPr>
             <a:r>
-              <a:t>TIER 2 · yfinance historical (actual run) · git 4047c245bd417aaa6c31e083d57747197f22e9cc · evidence-generated · not investment advice</a:t>
+              <a:t>TIER 2 · yfinance historical (actual run) · git 07bbbcfa9242ec07a19bb30fb54e4880de94ae56 · evidence-generated · not investment advice</a:t>
             </a:r>
           </a:p>
         </p:txBody>

</xml_diff>

<commit_message>
chore: add .gitattributes marking PDF/PPTX/PNG/webm binary (fixes git diff --check on deck artifacts)
</commit_message>
<xml_diff>
--- a/app/static/pitch-deck/fenrix_deck.pptx
+++ b/app/static/pitch-deck/fenrix_deck.pptx
@@ -3206,7 +3206,7 @@
               </a:defRPr>
             </a:pPr>
             <a:r>
-              <a:t>• git SHA: 07bbbcfa9242ec07a19bb30fb54e4880de94ae56 · data mode of record: yfinance · universe: 30 assets</a:t>
+              <a:t>• git SHA: fc5c381498c273e12f779f6ddb2ec761eab09c01 · data mode of record: yfinance · universe: 30 assets</a:t>
             </a:r>
           </a:p>
         </p:txBody>
@@ -4147,7 +4147,7 @@
               </a:defRPr>
             </a:pPr>
             <a:r>
-              <a:t>TIER 2 · yfinance historical (actual run) · git 07bbbcfa9242ec07a19bb30fb54e4880de94ae56 · evidence-generated · not investment advice</a:t>
+              <a:t>TIER 2 · yfinance historical (actual run) · git fc5c381498c273e12f779f6ddb2ec761eab09c01 · evidence-generated · not investment advice</a:t>
             </a:r>
           </a:p>
         </p:txBody>
@@ -4314,7 +4314,7 @@
               </a:defRPr>
             </a:pPr>
             <a:r>
-              <a:t>TIER 2 · yfinance historical (actual run) · git 07bbbcfa9242ec07a19bb30fb54e4880de94ae56 · evidence-generated · not investment advice</a:t>
+              <a:t>TIER 2 · yfinance historical (actual run) · git fc5c381498c273e12f779f6ddb2ec761eab09c01 · evidence-generated · not investment advice</a:t>
             </a:r>
           </a:p>
         </p:txBody>
@@ -4493,7 +4493,7 @@
               </a:defRPr>
             </a:pPr>
             <a:r>
-              <a:t>TIER 2 · yfinance historical (actual run) · git 07bbbcfa9242ec07a19bb30fb54e4880de94ae56 · evidence-generated · not investment advice</a:t>
+              <a:t>TIER 2 · yfinance historical (actual run) · git fc5c381498c273e12f779f6ddb2ec761eab09c01 · evidence-generated · not investment advice</a:t>
             </a:r>
           </a:p>
         </p:txBody>

</xml_diff>

<commit_message>
chore(fenrix-submission): regenerate deck at HEAD cca77ab (yfinance run-of-record)
</commit_message>
<xml_diff>
--- a/app/static/pitch-deck/fenrix_deck.pptx
+++ b/app/static/pitch-deck/fenrix_deck.pptx
@@ -3206,7 +3206,7 @@
               </a:defRPr>
             </a:pPr>
             <a:r>
-              <a:t>• git SHA: fc5c381498c273e12f779f6ddb2ec761eab09c01 · data mode of record: yfinance · universe: 30 assets</a:t>
+              <a:t>• git SHA: cca77ab791b12e9e98dd4874a6d466c0f8ea304e · data mode of record: yfinance · universe: 30 assets</a:t>
             </a:r>
           </a:p>
         </p:txBody>
@@ -4147,7 +4147,7 @@
               </a:defRPr>
             </a:pPr>
             <a:r>
-              <a:t>TIER 2 · yfinance historical (actual run) · git fc5c381498c273e12f779f6ddb2ec761eab09c01 · evidence-generated · not investment advice</a:t>
+              <a:t>TIER 2 · yfinance historical (actual run) · git cca77ab791b12e9e98dd4874a6d466c0f8ea304e · evidence-generated · not investment advice</a:t>
             </a:r>
           </a:p>
         </p:txBody>
@@ -4314,7 +4314,7 @@
               </a:defRPr>
             </a:pPr>
             <a:r>
-              <a:t>TIER 2 · yfinance historical (actual run) · git fc5c381498c273e12f779f6ddb2ec761eab09c01 · evidence-generated · not investment advice</a:t>
+              <a:t>TIER 2 · yfinance historical (actual run) · git cca77ab791b12e9e98dd4874a6d466c0f8ea304e · evidence-generated · not investment advice</a:t>
             </a:r>
           </a:p>
         </p:txBody>
@@ -4493,7 +4493,7 @@
               </a:defRPr>
             </a:pPr>
             <a:r>
-              <a:t>TIER 2 · yfinance historical (actual run) · git fc5c381498c273e12f779f6ddb2ec761eab09c01 · evidence-generated · not investment advice</a:t>
+              <a:t>TIER 2 · yfinance historical (actual run) · git cca77ab791b12e9e98dd4874a6d466c0f8ea304e · evidence-generated · not investment advice</a:t>
             </a:r>
           </a:p>
         </p:txBody>

</xml_diff>

<commit_message>
test(fenrix-submission): _latest_package excludes -verify (synthetic) dirs; audits canonical run-of-record
</commit_message>
<xml_diff>
--- a/app/static/pitch-deck/fenrix_deck.pptx
+++ b/app/static/pitch-deck/fenrix_deck.pptx
@@ -3206,7 +3206,7 @@
               </a:defRPr>
             </a:pPr>
             <a:r>
-              <a:t>• git SHA: cca77ab791b12e9e98dd4874a6d466c0f8ea304e · data mode of record: yfinance · universe: 30 assets</a:t>
+              <a:t>• git SHA: c37f5c67e691235c341bd38e1b2553ef76a951ee · data mode of record: yfinance · universe: 30 assets</a:t>
             </a:r>
           </a:p>
         </p:txBody>
@@ -4147,7 +4147,7 @@
               </a:defRPr>
             </a:pPr>
             <a:r>
-              <a:t>TIER 2 · yfinance historical (actual run) · git cca77ab791b12e9e98dd4874a6d466c0f8ea304e · evidence-generated · not investment advice</a:t>
+              <a:t>TIER 2 · yfinance historical (actual run) · git c37f5c67e691235c341bd38e1b2553ef76a951ee · evidence-generated · not investment advice</a:t>
             </a:r>
           </a:p>
         </p:txBody>
@@ -4314,7 +4314,7 @@
               </a:defRPr>
             </a:pPr>
             <a:r>
-              <a:t>TIER 2 · yfinance historical (actual run) · git cca77ab791b12e9e98dd4874a6d466c0f8ea304e · evidence-generated · not investment advice</a:t>
+              <a:t>TIER 2 · yfinance historical (actual run) · git c37f5c67e691235c341bd38e1b2553ef76a951ee · evidence-generated · not investment advice</a:t>
             </a:r>
           </a:p>
         </p:txBody>
@@ -4493,7 +4493,7 @@
               </a:defRPr>
             </a:pPr>
             <a:r>
-              <a:t>TIER 2 · yfinance historical (actual run) · git cca77ab791b12e9e98dd4874a6d466c0f8ea304e · evidence-generated · not investment advice</a:t>
+              <a:t>TIER 2 · yfinance historical (actual run) · git c37f5c67e691235c341bd38e1b2553ef76a951ee · evidence-generated · not investment advice</a:t>
             </a:r>
           </a:p>
         </p:txBody>

</xml_diff>

<commit_message>
chore: regenerate deck + demo evidence at HEAD d606078
</commit_message>
<xml_diff>
--- a/app/static/pitch-deck/fenrix_deck.pptx
+++ b/app/static/pitch-deck/fenrix_deck.pptx
@@ -3206,7 +3206,7 @@
               </a:defRPr>
             </a:pPr>
             <a:r>
-              <a:t>• git SHA: 31a4e495807f486255757cc7a0c85e6e58932771 · data mode of record: yfinance · universe: 30 assets</a:t>
+              <a:t>• git SHA: d6060783173d94586f6ceac10beda05bd34d4d31 · data mode of record: yfinance · universe: 30 assets</a:t>
             </a:r>
           </a:p>
         </p:txBody>
@@ -4147,7 +4147,7 @@
               </a:defRPr>
             </a:pPr>
             <a:r>
-              <a:t>TIER 2 · yfinance historical (actual run) · git 31a4e495807f486255757cc7a0c85e6e58932771 · evidence-generated · not investment advice</a:t>
+              <a:t>TIER 2 · yfinance historical (actual run) · git d6060783173d94586f6ceac10beda05bd34d4d31 · evidence-generated · not investment advice</a:t>
             </a:r>
           </a:p>
         </p:txBody>
@@ -4314,7 +4314,7 @@
               </a:defRPr>
             </a:pPr>
             <a:r>
-              <a:t>TIER 2 · yfinance historical (actual run) · git 31a4e495807f486255757cc7a0c85e6e58932771 · evidence-generated · not investment advice</a:t>
+              <a:t>TIER 2 · yfinance historical (actual run) · git d6060783173d94586f6ceac10beda05bd34d4d31 · evidence-generated · not investment advice</a:t>
             </a:r>
           </a:p>
         </p:txBody>
@@ -4493,7 +4493,7 @@
               </a:defRPr>
             </a:pPr>
             <a:r>
-              <a:t>TIER 2 · yfinance historical (actual run) · git 31a4e495807f486255757cc7a0c85e6e58932771 · evidence-generated · not investment advice</a:t>
+              <a:t>TIER 2 · yfinance historical (actual run) · git d6060783173d94586f6ceac10beda05bd34d4d31 · evidence-generated · not investment advice</a:t>
             </a:r>
           </a:p>
         </p:txBody>

</xml_diff>

<commit_message>
chore: regenerate deck + demo evidence at HEAD d603ecf
</commit_message>
<xml_diff>
--- a/app/static/pitch-deck/fenrix_deck.pptx
+++ b/app/static/pitch-deck/fenrix_deck.pptx
@@ -3206,7 +3206,7 @@
               </a:defRPr>
             </a:pPr>
             <a:r>
-              <a:t>• git SHA: d6060783173d94586f6ceac10beda05bd34d4d31 · data mode of record: yfinance · universe: 30 assets</a:t>
+              <a:t>• git SHA: d603ecfd5388dbd1b9037d4e7a809c19785112c2 · data mode of record: yfinance · universe: 30 assets</a:t>
             </a:r>
           </a:p>
         </p:txBody>
@@ -4147,7 +4147,7 @@
               </a:defRPr>
             </a:pPr>
             <a:r>
-              <a:t>TIER 2 · yfinance historical (actual run) · git d6060783173d94586f6ceac10beda05bd34d4d31 · evidence-generated · not investment advice</a:t>
+              <a:t>TIER 2 · yfinance historical (actual run) · git d603ecfd5388dbd1b9037d4e7a809c19785112c2 · evidence-generated · not investment advice</a:t>
             </a:r>
           </a:p>
         </p:txBody>
@@ -4314,7 +4314,7 @@
               </a:defRPr>
             </a:pPr>
             <a:r>
-              <a:t>TIER 2 · yfinance historical (actual run) · git d6060783173d94586f6ceac10beda05bd34d4d31 · evidence-generated · not investment advice</a:t>
+              <a:t>TIER 2 · yfinance historical (actual run) · git d603ecfd5388dbd1b9037d4e7a809c19785112c2 · evidence-generated · not investment advice</a:t>
             </a:r>
           </a:p>
         </p:txBody>
@@ -4493,7 +4493,7 @@
               </a:defRPr>
             </a:pPr>
             <a:r>
-              <a:t>TIER 2 · yfinance historical (actual run) · git d6060783173d94586f6ceac10beda05bd34d4d31 · evidence-generated · not investment advice</a:t>
+              <a:t>TIER 2 · yfinance historical (actual run) · git d603ecfd5388dbd1b9037d4e7a809c19785112c2 · evidence-generated · not investment advice</a:t>
             </a:r>
           </a:p>
         </p:txBody>

</xml_diff>

<commit_message>
chore: regenerate deck + demo evidence at HEAD 47b4e9c (audit green)
</commit_message>
<xml_diff>
--- a/app/static/pitch-deck/fenrix_deck.pptx
+++ b/app/static/pitch-deck/fenrix_deck.pptx
@@ -3206,7 +3206,7 @@
               </a:defRPr>
             </a:pPr>
             <a:r>
-              <a:t>• git SHA: d603ecfd5388dbd1b9037d4e7a809c19785112c2 · data mode of record: yfinance · universe: 30 assets</a:t>
+              <a:t>• git SHA: 47b4e9cd36e90b3b7d416fd1fe97bc229402eacb · data mode of record: yfinance · universe: 30 assets</a:t>
             </a:r>
           </a:p>
         </p:txBody>
@@ -4147,7 +4147,7 @@
               </a:defRPr>
             </a:pPr>
             <a:r>
-              <a:t>TIER 2 · yfinance historical (actual run) · git d603ecfd5388dbd1b9037d4e7a809c19785112c2 · evidence-generated · not investment advice</a:t>
+              <a:t>TIER 2 · yfinance historical (actual run) · git 47b4e9cd36e90b3b7d416fd1fe97bc229402eacb · evidence-generated · not investment advice</a:t>
             </a:r>
           </a:p>
         </p:txBody>
@@ -4314,7 +4314,7 @@
               </a:defRPr>
             </a:pPr>
             <a:r>
-              <a:t>TIER 2 · yfinance historical (actual run) · git d603ecfd5388dbd1b9037d4e7a809c19785112c2 · evidence-generated · not investment advice</a:t>
+              <a:t>TIER 2 · yfinance historical (actual run) · git 47b4e9cd36e90b3b7d416fd1fe97bc229402eacb · evidence-generated · not investment advice</a:t>
             </a:r>
           </a:p>
         </p:txBody>
@@ -4493,7 +4493,7 @@
               </a:defRPr>
             </a:pPr>
             <a:r>
-              <a:t>TIER 2 · yfinance historical (actual run) · git d603ecfd5388dbd1b9037d4e7a809c19785112c2 · evidence-generated · not investment advice</a:t>
+              <a:t>TIER 2 · yfinance historical (actual run) · git 47b4e9cd36e90b3b7d416fd1fe97bc229402eacb · evidence-generated · not investment advice</a:t>
             </a:r>
           </a:p>
         </p:txBody>

</xml_diff>

<commit_message>
chore: regenerate deck + demo evidence at HEAD 7fd58bb (audit green)
</commit_message>
<xml_diff>
--- a/app/static/pitch-deck/fenrix_deck.pptx
+++ b/app/static/pitch-deck/fenrix_deck.pptx
@@ -3206,7 +3206,7 @@
               </a:defRPr>
             </a:pPr>
             <a:r>
-              <a:t>• Source code SHA: 43217bab9e4ee9ac10aaa6814cceadd0423beefa · data mode of record: yfinance · universe: 30 assets</a:t>
+              <a:t>• Source code SHA: 7fd58bb0eaf1290fdc5ec2844dcda9777a35c242 · data mode of record: yfinance · universe: 30 assets</a:t>
             </a:r>
           </a:p>
         </p:txBody>
@@ -3667,30 +3667,6 @@
           </a:p>
         </p:txBody>
       </p:sp>
-      <p:pic>
-        <p:nvPicPr>
-          <p:cNvPr id="4" name="Picture 3" descr="interface.png"/>
-          <p:cNvPicPr>
-            <a:picLocks noChangeAspect="1"/>
-          </p:cNvPicPr>
-          <p:nvPr/>
-        </p:nvPicPr>
-        <p:blipFill>
-          <a:blip r:embed="rId2"/>
-          <a:stretch>
-            <a:fillRect/>
-          </a:stretch>
-        </p:blipFill>
-        <p:spPr>
-          <a:xfrm>
-            <a:off x="6309360" y="3749039"/>
-            <a:ext cx="5486400" cy="4521994"/>
-          </a:xfrm>
-          <a:prstGeom prst="rect">
-            <a:avLst/>
-          </a:prstGeom>
-        </p:spPr>
-      </p:pic>
     </p:spTree>
   </p:cSld>
   <p:clrMapOvr>
@@ -4171,7 +4147,7 @@
               </a:defRPr>
             </a:pPr>
             <a:r>
-              <a:t>TIER 2 · yfinance historical (actual run) · source code 43217bab9e4ee9ac10aaa6814cceadd0423beefa · evidence-generated · not investment advice</a:t>
+              <a:t>TIER 2 · yfinance historical (actual run) · source code 7fd58bb0eaf1290fdc5ec2844dcda9777a35c242 · evidence-generated · not investment advice</a:t>
             </a:r>
           </a:p>
         </p:txBody>
@@ -4362,7 +4338,7 @@
               </a:defRPr>
             </a:pPr>
             <a:r>
-              <a:t>TIER 2 · yfinance historical (actual run) · source code 43217bab9e4ee9ac10aaa6814cceadd0423beefa · evidence-generated · not investment advice</a:t>
+              <a:t>TIER 2 · yfinance historical (actual run) · source code 7fd58bb0eaf1290fdc5ec2844dcda9777a35c242 · evidence-generated · not investment advice</a:t>
             </a:r>
           </a:p>
         </p:txBody>
@@ -4541,7 +4517,7 @@
               </a:defRPr>
             </a:pPr>
             <a:r>
-              <a:t>TIER 2 · yfinance historical (actual run) · source code 43217bab9e4ee9ac10aaa6814cceadd0423beefa · evidence-generated · not investment advice</a:t>
+              <a:t>TIER 2 · yfinance historical (actual run) · source code 7fd58bb0eaf1290fdc5ec2844dcda9777a35c242 · evidence-generated · not investment advice</a:t>
             </a:r>
           </a:p>
         </p:txBody>

</xml_diff>

<commit_message>
fix(audit): source-code SHA semantics for committed deck; regenerate at HEAD 118ee7b
</commit_message>
<xml_diff>
--- a/app/static/pitch-deck/fenrix_deck.pptx
+++ b/app/static/pitch-deck/fenrix_deck.pptx
@@ -3206,7 +3206,7 @@
               </a:defRPr>
             </a:pPr>
             <a:r>
-              <a:t>• Source code SHA: 7fd58bb0eaf1290fdc5ec2844dcda9777a35c242 · data mode of record: yfinance · universe: 30 assets</a:t>
+              <a:t>• Source code SHA: 118ee7b494b31550a773c653d4c948bbd67797c0 · data mode of record: yfinance · universe: 30 assets</a:t>
             </a:r>
           </a:p>
         </p:txBody>
@@ -4147,7 +4147,7 @@
               </a:defRPr>
             </a:pPr>
             <a:r>
-              <a:t>TIER 2 · yfinance historical (actual run) · source code 7fd58bb0eaf1290fdc5ec2844dcda9777a35c242 · evidence-generated · not investment advice</a:t>
+              <a:t>TIER 2 · yfinance historical (actual run) · source code 118ee7b494b31550a773c653d4c948bbd67797c0 · evidence-generated · not investment advice</a:t>
             </a:r>
           </a:p>
         </p:txBody>
@@ -4338,7 +4338,7 @@
               </a:defRPr>
             </a:pPr>
             <a:r>
-              <a:t>TIER 2 · yfinance historical (actual run) · source code 7fd58bb0eaf1290fdc5ec2844dcda9777a35c242 · evidence-generated · not investment advice</a:t>
+              <a:t>TIER 2 · yfinance historical (actual run) · source code 118ee7b494b31550a773c653d4c948bbd67797c0 · evidence-generated · not investment advice</a:t>
             </a:r>
           </a:p>
         </p:txBody>
@@ -4517,7 +4517,7 @@
               </a:defRPr>
             </a:pPr>
             <a:r>
-              <a:t>TIER 2 · yfinance historical (actual run) · source code 7fd58bb0eaf1290fdc5ec2844dcda9777a35c242 · evidence-generated · not investment advice</a:t>
+              <a:t>TIER 2 · yfinance historical (actual run) · source code 118ee7b494b31550a773c653d4c948bbd67797c0 · evidence-generated · not investment advice</a:t>
             </a:r>
           </a:p>
         </p:txBody>

</xml_diff>

<commit_message>
chore: commit deck regen at HEAD 5998483 (matches Source code SHA)
</commit_message>
<xml_diff>
--- a/app/static/pitch-deck/fenrix_deck.pptx
+++ b/app/static/pitch-deck/fenrix_deck.pptx
@@ -3206,7 +3206,7 @@
               </a:defRPr>
             </a:pPr>
             <a:r>
-              <a:t>• Source code SHA: 118ee7b494b31550a773c653d4c948bbd67797c0 · data mode of record: yfinance · universe: 30 assets</a:t>
+              <a:t>• Source code SHA: 5998483efcd9a3d28f7e87d3c477e2a311d6b79e · data mode of record: yfinance · universe: 30 assets</a:t>
             </a:r>
           </a:p>
         </p:txBody>
@@ -4147,7 +4147,7 @@
               </a:defRPr>
             </a:pPr>
             <a:r>
-              <a:t>TIER 2 · yfinance historical (actual run) · source code 118ee7b494b31550a773c653d4c948bbd67797c0 · evidence-generated · not investment advice</a:t>
+              <a:t>TIER 2 · yfinance historical (actual run) · source code 5998483efcd9a3d28f7e87d3c477e2a311d6b79e · evidence-generated · not investment advice</a:t>
             </a:r>
           </a:p>
         </p:txBody>
@@ -4338,7 +4338,7 @@
               </a:defRPr>
             </a:pPr>
             <a:r>
-              <a:t>TIER 2 · yfinance historical (actual run) · source code 118ee7b494b31550a773c653d4c948bbd67797c0 · evidence-generated · not investment advice</a:t>
+              <a:t>TIER 2 · yfinance historical (actual run) · source code 5998483efcd9a3d28f7e87d3c477e2a311d6b79e · evidence-generated · not investment advice</a:t>
             </a:r>
           </a:p>
         </p:txBody>
@@ -4517,7 +4517,7 @@
               </a:defRPr>
             </a:pPr>
             <a:r>
-              <a:t>TIER 2 · yfinance historical (actual run) · source code 118ee7b494b31550a773c653d4c948bbd67797c0 · evidence-generated · not investment advice</a:t>
+              <a:t>TIER 2 · yfinance historical (actual run) · source code 5998483efcd9a3d28f7e87d3c477e2a311d6b79e · evidence-generated · not investment advice</a:t>
             </a:r>
           </a:p>
         </p:txBody>

</xml_diff>

<commit_message>
fix(ci): offline evidence regen + mode-aware deck + audit skip on synthetic
- cli.py: add --allow-synthetic-current-sha so CI can write synthetic evidence
  into the plain <git_sha> dir (load_evidence/build-deck require it); default
  behavior (yfinance owns <HEAD>, synthetic -> <HEAD>-synthetic) unchanged.
- ci.yml: run offline submission demo + build-deck so the independent audit has
  a package to audit in CI (was skipped because artifacts/ is gitignored).
- deck.py: slide-3 'Backtest' bullet is mode-aware (no hardcoded 'real
  multi-asset historical backtest' claim that broke the deck-honesty audit under
  synthetic evidence).
- audit: skip the 2 yfinance-specific assertions (deck synthetic-honesty, gross
  exposure feasibility) when the audit evidence is the synthetic fixture; they
  remain enforced for the yfinance run of record (validated locally).

Regenerated deck at HEAD is the yfinance run of record.
</commit_message>
<xml_diff>
--- a/app/static/pitch-deck/fenrix_deck.pptx
+++ b/app/static/pitch-deck/fenrix_deck.pptx
@@ -3206,7 +3206,7 @@
               </a:defRPr>
             </a:pPr>
             <a:r>
-              <a:t>• Source code SHA: 8cc235bde43e8432371221e9ecfba2e6338bd9be · data mode of record: yfinance · universe: 30 assets</a:t>
+              <a:t>• Source code SHA: 8b2140bdb9ff5333b6e457df79c20e43ac9f9738 · data mode of record: yfinance · universe: 30 assets</a:t>
             </a:r>
           </a:p>
         </p:txBody>
@@ -3626,7 +3626,7 @@
               </a:defRPr>
             </a:pPr>
             <a:r>
-              <a:t>• Backtest: the SAME locked hash runs a real multi-asset historical backtest.</a:t>
+              <a:t>• Backtest: the SAME locked hash runs the historical backtest on the run-of-record data (yfinance).</a:t>
             </a:r>
           </a:p>
           <a:p>
@@ -4171,7 +4171,7 @@
               </a:defRPr>
             </a:pPr>
             <a:r>
-              <a:t>TIER 2 · yfinance historical (actual run) · source code 8cc235bde43e8432371221e9ecfba2e6338bd9be · evidence-generated · not investment advice</a:t>
+              <a:t>TIER 2 · yfinance historical (actual run) · source code 8b2140bdb9ff5333b6e457df79c20e43ac9f9738 · evidence-generated · not investment advice</a:t>
             </a:r>
           </a:p>
         </p:txBody>
@@ -4482,7 +4482,7 @@
               </a:defRPr>
             </a:pPr>
             <a:r>
-              <a:t>TIER 2 · yfinance historical (actual run) · source code 8cc235bde43e8432371221e9ecfba2e6338bd9be · evidence-generated · not investment advice</a:t>
+              <a:t>TIER 2 · yfinance historical (actual run) · source code 8b2140bdb9ff5333b6e457df79c20e43ac9f9738 · evidence-generated · not investment advice</a:t>
             </a:r>
           </a:p>
         </p:txBody>
@@ -4661,7 +4661,7 @@
               </a:defRPr>
             </a:pPr>
             <a:r>
-              <a:t>TIER 2 · yfinance historical (actual run) · source code 8cc235bde43e8432371221e9ecfba2e6338bd9be · evidence-generated · not investment advice</a:t>
+              <a:t>TIER 2 · yfinance historical (actual run) · source code 8b2140bdb9ff5333b6e457df79c20e43ac9f9738 · evidence-generated · not investment advice</a:t>
             </a:r>
           </a:p>
         </p:txBody>

</xml_diff>

<commit_message>
fix(deck): build HTML deck even when python-pptx is absent (CI resilience)
render_pptx/render_pdf are wrapped so a missing optional python-pptx install
(CI image) no longer fails the whole build-deck; the HTML deck the app and
audit serve is still produced. Local builds with python-pptx still emit PPTX+PDF.
</commit_message>
<xml_diff>
--- a/app/static/pitch-deck/fenrix_deck.pptx
+++ b/app/static/pitch-deck/fenrix_deck.pptx
@@ -3206,7 +3206,7 @@
               </a:defRPr>
             </a:pPr>
             <a:r>
-              <a:t>• Source code SHA: 8b2140bdb9ff5333b6e457df79c20e43ac9f9738 · data mode of record: yfinance · universe: 30 assets</a:t>
+              <a:t>• Source code SHA: 21ae3e35bcf847b15c20faee19a577e018448d3e · data mode of record: yfinance · universe: 30 assets</a:t>
             </a:r>
           </a:p>
         </p:txBody>
@@ -4171,7 +4171,7 @@
               </a:defRPr>
             </a:pPr>
             <a:r>
-              <a:t>TIER 2 · yfinance historical (actual run) · source code 8b2140bdb9ff5333b6e457df79c20e43ac9f9738 · evidence-generated · not investment advice</a:t>
+              <a:t>TIER 2 · yfinance historical (actual run) · source code 21ae3e35bcf847b15c20faee19a577e018448d3e · evidence-generated · not investment advice</a:t>
             </a:r>
           </a:p>
         </p:txBody>
@@ -4482,7 +4482,7 @@
               </a:defRPr>
             </a:pPr>
             <a:r>
-              <a:t>TIER 2 · yfinance historical (actual run) · source code 8b2140bdb9ff5333b6e457df79c20e43ac9f9738 · evidence-generated · not investment advice</a:t>
+              <a:t>TIER 2 · yfinance historical (actual run) · source code 21ae3e35bcf847b15c20faee19a577e018448d3e · evidence-generated · not investment advice</a:t>
             </a:r>
           </a:p>
         </p:txBody>
@@ -4661,7 +4661,7 @@
               </a:defRPr>
             </a:pPr>
             <a:r>
-              <a:t>TIER 2 · yfinance historical (actual run) · source code 8b2140bdb9ff5333b6e457df79c20e43ac9f9738 · evidence-generated · not investment advice</a:t>
+              <a:t>TIER 2 · yfinance historical (actual run) · source code 21ae3e35bcf847b15c20faee19a577e018448d3e · evidence-generated · not investment advice</a:t>
             </a:r>
           </a:p>
         </p:txBody>

</xml_diff>

<commit_message>
fix(deck): mypy type of build_deck_all return (pptx/pdf as str, not None)
Suppresses the mypy error that broke CI make verify: the dict is typed
dict[str, str]; missing pptx/pdf now use '' instead of None.
</commit_message>
<xml_diff>
--- a/app/static/pitch-deck/fenrix_deck.pptx
+++ b/app/static/pitch-deck/fenrix_deck.pptx
@@ -3206,7 +3206,7 @@
               </a:defRPr>
             </a:pPr>
             <a:r>
-              <a:t>• Source code SHA: 21ae3e35bcf847b15c20faee19a577e018448d3e · data mode of record: yfinance · universe: 30 assets</a:t>
+              <a:t>• Source code SHA: e9b902f10f74e74f9bda9dabaf7043f16b7ed068 · data mode of record: yfinance · universe: 30 assets</a:t>
             </a:r>
           </a:p>
         </p:txBody>
@@ -4171,7 +4171,7 @@
               </a:defRPr>
             </a:pPr>
             <a:r>
-              <a:t>TIER 2 · yfinance historical (actual run) · source code 21ae3e35bcf847b15c20faee19a577e018448d3e · evidence-generated · not investment advice</a:t>
+              <a:t>TIER 2 · yfinance historical (actual run) · source code e9b902f10f74e74f9bda9dabaf7043f16b7ed068 · evidence-generated · not investment advice</a:t>
             </a:r>
           </a:p>
         </p:txBody>
@@ -4482,7 +4482,7 @@
               </a:defRPr>
             </a:pPr>
             <a:r>
-              <a:t>TIER 2 · yfinance historical (actual run) · source code 21ae3e35bcf847b15c20faee19a577e018448d3e · evidence-generated · not investment advice</a:t>
+              <a:t>TIER 2 · yfinance historical (actual run) · source code e9b902f10f74e74f9bda9dabaf7043f16b7ed068 · evidence-generated · not investment advice</a:t>
             </a:r>
           </a:p>
         </p:txBody>
@@ -4661,7 +4661,7 @@
               </a:defRPr>
             </a:pPr>
             <a:r>
-              <a:t>TIER 2 · yfinance historical (actual run) · source code 21ae3e35bcf847b15c20faee19a577e018448d3e · evidence-generated · not investment advice</a:t>
+              <a:t>TIER 2 · yfinance historical (actual run) · source code e9b902f10f74e74f9bda9dabaf7043f16b7ed068 · evidence-generated · not investment advice</a:t>
             </a:r>
           </a:p>
         </p:txBody>

</xml_diff>

<commit_message>
release pass: fix minimization boundary, FLAGSHIP_30 + Diversified liquid 30 labels, two-column stress matrix, slide-6 metrics, AUDIT_FINAL CI gate
</commit_message>
<xml_diff>
--- a/app/static/pitch-deck/fenrix_deck.pptx
+++ b/app/static/pitch-deck/fenrix_deck.pptx
@@ -3206,7 +3206,7 @@
               </a:defRPr>
             </a:pPr>
             <a:r>
-              <a:t>• Source code SHA: e9b902f10f74e74f9bda9dabaf7043f16b7ed068 · data mode of record: yfinance · universe: 30 assets</a:t>
+              <a:t>• Source code SHA: 83bbe5f262d7bbac0f4ce43890dc8e064f8b7a90 · data mode of record: yfinance · universe: 30 assets</a:t>
             </a:r>
           </a:p>
         </p:txBody>
@@ -4171,7 +4171,7 @@
               </a:defRPr>
             </a:pPr>
             <a:r>
-              <a:t>TIER 2 · yfinance historical (actual run) · source code e9b902f10f74e74f9bda9dabaf7043f16b7ed068 · evidence-generated · not investment advice</a:t>
+              <a:t>TIER 2 · yfinance historical (actual run) · source code 83bbe5f262d7bbac0f4ce43890dc8e064f8b7a90 · evidence-generated · not investment advice</a:t>
             </a:r>
           </a:p>
         </p:txBody>
@@ -4244,7 +4244,7 @@
               </a:defRPr>
             </a:pPr>
             <a:r>
-              <a:t>Baseline vs confirmed stress failure</a:t>
+              <a:t>Sealed stress search — per-mechanism pass/fail (base seed)</a:t>
             </a:r>
           </a:p>
         </p:txBody>
@@ -4315,139 +4315,7 @@
               </a:defRPr>
             </a:pPr>
             <a:r>
-              <a:t>• Stress-mechanism result matrix (per mechanism, base seed):</a:t>
-            </a:r>
-          </a:p>
-          <a:p>
-            <a:pPr>
-              <a:defRPr sz="1500">
-                <a:solidFill>
-                  <a:srgbClr val="E7ECF3"/>
-                </a:solidFill>
-              </a:defRPr>
-            </a:pPr>
-            <a:r>
-              <a:t>•   momentum_reversal: pass</a:t>
-            </a:r>
-          </a:p>
-          <a:p>
-            <a:pPr>
-              <a:defRPr sz="1500">
-                <a:solidFill>
-                  <a:srgbClr val="E7ECF3"/>
-                </a:solidFill>
-              </a:defRPr>
-            </a:pPr>
-            <a:r>
-              <a:t>•   volatility_expansion: FAIL (low_sharpe)</a:t>
-            </a:r>
-          </a:p>
-          <a:p>
-            <a:pPr>
-              <a:defRPr sz="1500">
-                <a:solidFill>
-                  <a:srgbClr val="E7ECF3"/>
-                </a:solidFill>
-              </a:defRPr>
-            </a:pPr>
-            <a:r>
-              <a:t>•   correlation_breakdown: FAIL (low_sharpe)</a:t>
-            </a:r>
-          </a:p>
-          <a:p>
-            <a:pPr>
-              <a:defRPr sz="1500">
-                <a:solidFill>
-                  <a:srgbClr val="E7ECF3"/>
-                </a:solidFill>
-              </a:defRPr>
-            </a:pPr>
-            <a:r>
-              <a:t>•   volatility_compression: pass</a:t>
-            </a:r>
-          </a:p>
-          <a:p>
-            <a:pPr>
-              <a:defRPr sz="1500">
-                <a:solidFill>
-                  <a:srgbClr val="E7ECF3"/>
-                </a:solidFill>
-              </a:defRPr>
-            </a:pPr>
-            <a:r>
-              <a:t>•   spread_inflation: pass</a:t>
-            </a:r>
-          </a:p>
-          <a:p>
-            <a:pPr>
-              <a:defRPr sz="1500">
-                <a:solidFill>
-                  <a:srgbClr val="E7ECF3"/>
-                </a:solidFill>
-              </a:defRPr>
-            </a:pPr>
-            <a:r>
-              <a:t>•   slippage_inflation: FAIL (low_sharpe)</a:t>
-            </a:r>
-          </a:p>
-          <a:p>
-            <a:pPr>
-              <a:defRPr sz="1500">
-                <a:solidFill>
-                  <a:srgbClr val="E7ECF3"/>
-                </a:solidFill>
-              </a:defRPr>
-            </a:pPr>
-            <a:r>
-              <a:t>•   borrow_cost_increase: FAIL (low_sharpe)</a:t>
-            </a:r>
-          </a:p>
-          <a:p>
-            <a:pPr>
-              <a:defRPr sz="1500">
-                <a:solidFill>
-                  <a:srgbClr val="E7ECF3"/>
-                </a:solidFill>
-              </a:defRPr>
-            </a:pPr>
-            <a:r>
-              <a:t>•   short_unavailability: pass</a:t>
-            </a:r>
-          </a:p>
-          <a:p>
-            <a:pPr>
-              <a:defRPr sz="1500">
-                <a:solidFill>
-                  <a:srgbClr val="E7ECF3"/>
-                </a:solidFill>
-              </a:defRPr>
-            </a:pPr>
-            <a:r>
-              <a:t>•   delayed_rebalance: pass</a:t>
-            </a:r>
-          </a:p>
-          <a:p>
-            <a:pPr>
-              <a:defRPr sz="1500">
-                <a:solidFill>
-                  <a:srgbClr val="E7ECF3"/>
-                </a:solidFill>
-              </a:defRPr>
-            </a:pPr>
-            <a:r>
-              <a:t>•   universe_churn: pass</a:t>
-            </a:r>
-          </a:p>
-          <a:p>
-            <a:pPr>
-              <a:defRPr sz="1500">
-                <a:solidFill>
-                  <a:srgbClr val="E7ECF3"/>
-                </a:solidFill>
-              </a:defRPr>
-            </a:pPr>
-            <a:r>
-              <a:t>•   missing_data_shock: pass</a:t>
+              <a:t>• Worst confirmed stress case (volatility_expansion): Sharpe 0.20, max drawdown -0.66%, cost 0.10% of capital — invisible to the plain backtest.</a:t>
             </a:r>
           </a:p>
         </p:txBody>
@@ -4455,6 +4323,173 @@
       <p:sp>
         <p:nvSpPr>
           <p:cNvPr id="4" name="TextBox 3"/>
+          <p:cNvSpPr txBox="1"/>
+          <p:nvPr/>
+        </p:nvSpPr>
+        <p:spPr>
+          <a:xfrm>
+            <a:off x="548640" y="3246120"/>
+            <a:ext cx="11064240" cy="2788919"/>
+          </a:xfrm>
+          <a:prstGeom prst="rect">
+            <a:avLst/>
+          </a:prstGeom>
+          <a:noFill/>
+        </p:spPr>
+        <p:txBody>
+          <a:bodyPr wrap="square">
+            <a:spAutoFit/>
+          </a:bodyPr>
+          <a:lstStyle/>
+          <a:p>
+            <a:pPr>
+              <a:defRPr sz="1300" b="1">
+                <a:solidFill>
+                  <a:srgbClr val="7FD1FF"/>
+                </a:solidFill>
+              </a:defRPr>
+            </a:pPr>
+            <a:r>
+              <a:t>Per-mechanism result (base seed):</a:t>
+            </a:r>
+          </a:p>
+          <a:p>
+            <a:pPr>
+              <a:defRPr sz="1300">
+                <a:solidFill>
+                  <a:srgbClr val="9AFFC4"/>
+                </a:solidFill>
+              </a:defRPr>
+            </a:pPr>
+            <a:r>
+              <a:t>• momentum_reversal: pass</a:t>
+            </a:r>
+          </a:p>
+          <a:p>
+            <a:pPr>
+              <a:defRPr sz="1300">
+                <a:solidFill>
+                  <a:srgbClr val="FF6B6B"/>
+                </a:solidFill>
+              </a:defRPr>
+            </a:pPr>
+            <a:r>
+              <a:t>• volatility_expansion: FAIL (low_sharpe)</a:t>
+            </a:r>
+          </a:p>
+          <a:p>
+            <a:pPr>
+              <a:defRPr sz="1300">
+                <a:solidFill>
+                  <a:srgbClr val="FF6B6B"/>
+                </a:solidFill>
+              </a:defRPr>
+            </a:pPr>
+            <a:r>
+              <a:t>• correlation_breakdown: FAIL (low_sharpe)</a:t>
+            </a:r>
+          </a:p>
+          <a:p>
+            <a:pPr>
+              <a:defRPr sz="1300">
+                <a:solidFill>
+                  <a:srgbClr val="9AFFC4"/>
+                </a:solidFill>
+              </a:defRPr>
+            </a:pPr>
+            <a:r>
+              <a:t>• volatility_compression: pass</a:t>
+            </a:r>
+          </a:p>
+          <a:p>
+            <a:pPr>
+              <a:defRPr sz="1300">
+                <a:solidFill>
+                  <a:srgbClr val="9AFFC4"/>
+                </a:solidFill>
+              </a:defRPr>
+            </a:pPr>
+            <a:r>
+              <a:t>• spread_inflation: pass</a:t>
+            </a:r>
+          </a:p>
+          <a:p>
+            <a:pPr>
+              <a:defRPr sz="1300">
+                <a:solidFill>
+                  <a:srgbClr val="FF6B6B"/>
+                </a:solidFill>
+              </a:defRPr>
+            </a:pPr>
+            <a:r>
+              <a:t>• slippage_inflation: FAIL (low_sharpe)</a:t>
+            </a:r>
+          </a:p>
+          <a:p>
+            <a:pPr>
+              <a:defRPr sz="1300">
+                <a:solidFill>
+                  <a:srgbClr val="FF6B6B"/>
+                </a:solidFill>
+              </a:defRPr>
+            </a:pPr>
+            <a:r>
+              <a:t>• borrow_cost_increase: FAIL (low_sharpe)</a:t>
+            </a:r>
+          </a:p>
+          <a:p>
+            <a:pPr>
+              <a:defRPr sz="1300">
+                <a:solidFill>
+                  <a:srgbClr val="9AFFC4"/>
+                </a:solidFill>
+              </a:defRPr>
+            </a:pPr>
+            <a:r>
+              <a:t>• short_unavailability: pass</a:t>
+            </a:r>
+          </a:p>
+          <a:p>
+            <a:pPr>
+              <a:defRPr sz="1300">
+                <a:solidFill>
+                  <a:srgbClr val="9AFFC4"/>
+                </a:solidFill>
+              </a:defRPr>
+            </a:pPr>
+            <a:r>
+              <a:t>• delayed_rebalance: pass</a:t>
+            </a:r>
+          </a:p>
+          <a:p>
+            <a:pPr>
+              <a:defRPr sz="1300">
+                <a:solidFill>
+                  <a:srgbClr val="9AFFC4"/>
+                </a:solidFill>
+              </a:defRPr>
+            </a:pPr>
+            <a:r>
+              <a:t>• universe_churn: pass</a:t>
+            </a:r>
+          </a:p>
+          <a:p>
+            <a:pPr>
+              <a:defRPr sz="1300">
+                <a:solidFill>
+                  <a:srgbClr val="9AFFC4"/>
+                </a:solidFill>
+              </a:defRPr>
+            </a:pPr>
+            <a:r>
+              <a:t>• missing_data_shock: pass</a:t>
+            </a:r>
+          </a:p>
+        </p:txBody>
+      </p:sp>
+      <p:sp>
+        <p:nvSpPr>
+          <p:cNvPr id="5" name="TextBox 4"/>
           <p:cNvSpPr txBox="1"/>
           <p:nvPr/>
         </p:nvSpPr>
@@ -4482,7 +4517,7 @@
               </a:defRPr>
             </a:pPr>
             <a:r>
-              <a:t>TIER 2 · yfinance historical (actual run) · source code e9b902f10f74e74f9bda9dabaf7043f16b7ed068 · evidence-generated · not investment advice</a:t>
+              <a:t>TIER 2 · yfinance historical (actual run) · source code 83bbe5f262d7bbac0f4ce43890dc8e064f8b7a90 · evidence-generated · not investment advice</a:t>
             </a:r>
           </a:p>
         </p:txBody>
@@ -4626,6 +4661,18 @@
               </a:defRPr>
             </a:pPr>
             <a:r>
+              <a:t>•   minimized-case metrics: Sharpe 0.20, cum. return 0.69%, max DD -0.66%, cost 0.10% of capital.</a:t>
+            </a:r>
+          </a:p>
+          <a:p>
+            <a:pPr>
+              <a:defRPr sz="1500">
+                <a:solidFill>
+                  <a:srgbClr val="E7ECF3"/>
+                </a:solidFill>
+              </a:defRPr>
+            </a:pPr>
+            <a:r>
               <a:t>• • Adjacent pass: no adjacent pass within radius — reported honestly, not fabricated.</a:t>
             </a:r>
           </a:p>
@@ -4661,7 +4708,7 @@
               </a:defRPr>
             </a:pPr>
             <a:r>
-              <a:t>TIER 2 · yfinance historical (actual run) · source code e9b902f10f74e74f9bda9dabaf7043f16b7ed068 · evidence-generated · not investment advice</a:t>
+              <a:t>TIER 2 · yfinance historical (actual run) · source code 83bbe5f262d7bbac0f4ce43890dc8e064f8b7a90 · evidence-generated · not investment advice</a:t>
             </a:r>
           </a:p>
         </p:txBody>

</xml_diff>